<commit_message>
Updated the powerpoint presentation in docs
</commit_message>
<xml_diff>
--- a/docs/SkyCast_Project_Report_REZASHAHWAZ.pptx
+++ b/docs/SkyCast_Project_Report_REZASHAHWAZ.pptx
@@ -137,7 +137,10 @@
 <file path=ppt/revisionInfo.xml><?xml version="1.0" encoding="utf-8"?>
 <p1510:revInfo xmlns:a="http://schemas.openxmlformats.org/drawingml/2006/main" xmlns:r="http://schemas.openxmlformats.org/officeDocument/2006/relationships" xmlns:p1510="http://schemas.microsoft.com/office/powerpoint/2015/10/main">
   <p1510:revLst>
+    <p1510:client id="{00000000-0000-0000-0000-000000000000}" v="3" dt="2026-10-11T07:32:27.544"/>
+    <p1510:client id="{AC4A7D52-E8AB-3506-9A2D-FDE1A542B6BF}" v="246" dt="2026-10-11T09:02:50.330"/>
     <p1510:client id="{DB74E4F7-2585-6029-B9C2-D751FA2CF8CB}" v="1085" dt="2026-10-10T23:38:11.854"/>
+    <p1510:client id="{E4A8470B-4E27-40AE-7B91-B5CE1B1F7A72}" v="6" dt="2026-10-11T07:31:36.137"/>
   </p1510:revLst>
 </p1510:revInfo>
 </file>
@@ -223,7 +226,7 @@
           </a:lstStyle>
           <a:p>
             <a:fld id="{002B1B2C-E636-41F6-BBDA-551817183766}" type="datetimeFigureOut">
-              <a:t>10/10/2026</a:t>
+              <a:t>10/11/2026</a:t>
             </a:fld>
             <a:endParaRPr lang="en-US"/>
           </a:p>
@@ -818,7 +821,7 @@
           <a:p>
             <a:fld id="{F7021451-1387-4CA6-816F-3879F97B5CBC}" type="slidenum">
               <a:rPr lang="en-US"/>
-              <a:t>15</a:t>
+              <a:t>12</a:t>
             </a:fld>
             <a:endParaRPr lang="en-US"/>
           </a:p>
@@ -905,7 +908,7 @@
           <a:p>
             <a:fld id="{F7021451-1387-4CA6-816F-3879F97B5CBC}" type="slidenum">
               <a:rPr lang="en-US"/>
-              <a:t>16</a:t>
+              <a:t>13</a:t>
             </a:fld>
             <a:endParaRPr lang="en-US"/>
           </a:p>
@@ -992,7 +995,7 @@
           <a:p>
             <a:fld id="{F7021451-1387-4CA6-816F-3879F97B5CBC}" type="slidenum">
               <a:rPr lang="en-US"/>
-              <a:t>17</a:t>
+              <a:t>14</a:t>
             </a:fld>
             <a:endParaRPr lang="en-US"/>
           </a:p>
@@ -1079,7 +1082,7 @@
           <a:p>
             <a:fld id="{F7021451-1387-4CA6-816F-3879F97B5CBC}" type="slidenum">
               <a:rPr lang="en-US"/>
-              <a:t>18</a:t>
+              <a:t>15</a:t>
             </a:fld>
             <a:endParaRPr lang="en-US"/>
           </a:p>
@@ -1166,7 +1169,7 @@
           <a:p>
             <a:fld id="{F7021451-1387-4CA6-816F-3879F97B5CBC}" type="slidenum">
               <a:rPr lang="en-US"/>
-              <a:t>21</a:t>
+              <a:t>16</a:t>
             </a:fld>
             <a:endParaRPr lang="en-US"/>
           </a:p>
@@ -1253,7 +1256,7 @@
           <a:p>
             <a:fld id="{F7021451-1387-4CA6-816F-3879F97B5CBC}" type="slidenum">
               <a:rPr lang="en-US"/>
-              <a:t>22</a:t>
+              <a:t>17</a:t>
             </a:fld>
             <a:endParaRPr lang="en-US"/>
           </a:p>
@@ -1340,7 +1343,7 @@
           <a:p>
             <a:fld id="{F7021451-1387-4CA6-816F-3879F97B5CBC}" type="slidenum">
               <a:rPr lang="en-US"/>
-              <a:t>24</a:t>
+              <a:t>18</a:t>
             </a:fld>
             <a:endParaRPr lang="en-US"/>
           </a:p>
@@ -1427,7 +1430,7 @@
           <a:p>
             <a:fld id="{F7021451-1387-4CA6-816F-3879F97B5CBC}" type="slidenum">
               <a:rPr lang="en-US"/>
-              <a:t>25</a:t>
+              <a:t>19</a:t>
             </a:fld>
             <a:endParaRPr lang="en-US"/>
           </a:p>
@@ -1712,7 +1715,7 @@
           <a:p>
             <a:fld id="{F7021451-1387-4CA6-816F-3879F97B5CBC}" type="slidenum">
               <a:rPr lang="en-US"/>
-              <a:t>28</a:t>
+              <a:t>22</a:t>
             </a:fld>
             <a:endParaRPr lang="en-US"/>
           </a:p>
@@ -1796,7 +1799,7 @@
           <a:p>
             <a:fld id="{F7021451-1387-4CA6-816F-3879F97B5CBC}" type="slidenum">
               <a:rPr lang="en-US"/>
-              <a:t>29</a:t>
+              <a:t>23</a:t>
             </a:fld>
             <a:endParaRPr lang="en-US"/>
           </a:p>
@@ -7793,7 +7796,7 @@
           </a:prstGeom>
           <a:extLst>
             <a:ext uri="{C572A759-6A51-4108-AA02-DFA0A04FC94B}">
-              <ma14:wrappingTextBoxFlag xmlns="" xmlns:ma14="http://schemas.microsoft.com/office/mac/drawingml/2011/main" val="0"/>
+              <ma14:wrappingTextBoxFlag xmlns:ma14="http://schemas.microsoft.com/office/mac/drawingml/2011/main" xmlns="" val="0"/>
             </a:ext>
           </a:extLst>
         </p:spPr>
@@ -18326,6 +18329,77 @@
           </a:prstGeom>
         </p:spPr>
       </p:pic>
+      <p:sp>
+        <p:nvSpPr>
+          <p:cNvPr id="3" name="TextBox 2">
+            <a:extLst>
+              <a:ext uri="{FF2B5EF4-FFF2-40B4-BE49-F238E27FC236}">
+                <a16:creationId xmlns:a16="http://schemas.microsoft.com/office/drawing/2014/main" id="{98E72D6C-2917-A469-277A-494FBED91AF8}"/>
+              </a:ext>
+            </a:extLst>
+          </p:cNvPr>
+          <p:cNvSpPr txBox="1"/>
+          <p:nvPr/>
+        </p:nvSpPr>
+        <p:spPr>
+          <a:xfrm>
+            <a:off x="547588" y="6206858"/>
+            <a:ext cx="8924724" cy="430887"/>
+          </a:xfrm>
+          <a:prstGeom prst="rect">
+            <a:avLst/>
+          </a:prstGeom>
+          <a:noFill/>
+        </p:spPr>
+        <p:txBody>
+          <a:bodyPr rot="0" spcFirstLastPara="0" vertOverflow="overflow" horzOverflow="overflow" vert="horz" wrap="square" lIns="91440" tIns="45720" rIns="91440" bIns="45720" numCol="1" spcCol="0" rtlCol="0" fromWordArt="0" anchor="t" anchorCtr="0" forceAA="0" compatLnSpc="1">
+            <a:prstTxWarp prst="textNoShape">
+              <a:avLst/>
+            </a:prstTxWarp>
+            <a:spAutoFit/>
+          </a:bodyPr>
+          <a:lstStyle/>
+          <a:p>
+            <a:r>
+              <a:rPr lang="en-US" sz="1100" dirty="0">
+                <a:solidFill>
+                  <a:schemeClr val="bg1"/>
+                </a:solidFill>
+              </a:rPr>
+              <a:t>Disclaimer: Artificial Intelligence was used in order to design some aspects of this presentation. While the idea and execution are </a:t>
+            </a:r>
+            <a:r>
+              <a:rPr lang="en-US" sz="1100" b="1" dirty="0">
+                <a:solidFill>
+                  <a:schemeClr val="bg1"/>
+                </a:solidFill>
+              </a:rPr>
+              <a:t>completely mine</a:t>
+            </a:r>
+            <a:r>
+              <a:rPr lang="en-US" sz="1100" dirty="0">
+                <a:solidFill>
+                  <a:schemeClr val="bg1"/>
+                </a:solidFill>
+              </a:rPr>
+              <a:t>, AI helped me outline, design, and </a:t>
+            </a:r>
+            <a:r>
+              <a:rPr lang="en-US" sz="1100">
+                <a:solidFill>
+                  <a:schemeClr val="bg1"/>
+                </a:solidFill>
+              </a:rPr>
+              <a:t>complete this presentation.</a:t>
+            </a:r>
+            <a:endParaRPr lang="en-US" sz="1100" dirty="0">
+              <a:solidFill>
+                <a:schemeClr val="bg1"/>
+              </a:solidFill>
+            </a:endParaRPr>
+          </a:p>
+        </p:txBody>
+      </p:sp>
     </p:spTree>
   </p:cSld>
   <p:clrMapOvr>
@@ -19407,30 +19481,6 @@
           </a:ln>
         </p:spPr>
       </p:sp>
-      <p:pic>
-        <p:nvPicPr>
-          <p:cNvPr id="6" name="icon-MdWbSunny" descr="preencoded.png"/>
-          <p:cNvPicPr>
-            <a:picLocks noChangeAspect="1"/>
-          </p:cNvPicPr>
-          <p:nvPr/>
-        </p:nvPicPr>
-        <p:blipFill>
-          <a:blip r:embed="rId3"/>
-          <a:stretch>
-            <a:fillRect/>
-          </a:stretch>
-        </p:blipFill>
-        <p:spPr>
-          <a:xfrm>
-            <a:off x="689458" y="1695298"/>
-            <a:ext cx="358445" cy="358445"/>
-          </a:xfrm>
-          <a:prstGeom prst="rect">
-            <a:avLst/>
-          </a:prstGeom>
-        </p:spPr>
-      </p:pic>
       <p:sp>
         <p:nvSpPr>
           <p:cNvPr id="7" name="Text 3"/>
@@ -19512,30 +19562,6 @@
           </a:ln>
         </p:spPr>
       </p:sp>
-      <p:pic>
-        <p:nvPicPr>
-          <p:cNvPr id="9" name="icon-MdShowChart" descr="preencoded.png"/>
-          <p:cNvPicPr>
-            <a:picLocks noChangeAspect="1"/>
-          </p:cNvPicPr>
-          <p:nvPr/>
-        </p:nvPicPr>
-        <p:blipFill>
-          <a:blip r:embed="rId4"/>
-          <a:stretch>
-            <a:fillRect/>
-          </a:stretch>
-        </p:blipFill>
-        <p:spPr>
-          <a:xfrm>
-            <a:off x="689458" y="2609698"/>
-            <a:ext cx="358445" cy="358445"/>
-          </a:xfrm>
-          <a:prstGeom prst="rect">
-            <a:avLst/>
-          </a:prstGeom>
-        </p:spPr>
-      </p:pic>
       <p:sp>
         <p:nvSpPr>
           <p:cNvPr id="10" name="Text 5"/>
@@ -19849,7 +19875,7 @@
         </p:nvSpPr>
         <p:spPr>
           <a:xfrm>
-            <a:off x="691007" y="1684695"/>
+            <a:off x="691007" y="1689925"/>
             <a:ext cx="2743200" cy="365760"/>
           </a:xfrm>
           <a:prstGeom prst="rect">

</xml_diff>